<commit_message>
feat(ui): align history labels, autosave reason and command search
Vue, Svelte and Vanilla pass undo/redo labels to the title bar like React and
Angular; Svelte passes the disabled-by-host autosave reason so all five show
the same status; Vanilla runs the shared command-search ids through the ribbon's
own surfaces and offers the Find in Slides row. Adds drift tests, including a
cross-binding comparison of the search rows.

Closes #394

Co-Authored-By: Claude Sonnet 5.5 <noreply@anthropic.com>
Claude-Session: https://claude.ai/code/session_01N8pgK57Pbi6RyC2Rnyab88
</commit_message>
<xml_diff>
--- a/viewers/pptx/e2e/fixtures/box-cube-transition.pptx
+++ b/viewers/pptx/e2e/fixtures/box-cube-transition.pptx
@@ -420,12 +420,10 @@
           <a:bodyPr wrap="square"/>
           <a:lstStyle/>
           <a:p>
-            <a:pPr/>
             <a:r>
-              <a:rPr lang="en-US" dirty="0" sz="2400" b="1"/>
+              <a:rPr lang="en-US" sz="2400" b="1" dirty="0"/>
               <a:t>Slide One</a:t>
             </a:r>
-            <a:endParaRPr lang="en-US"/>
           </a:p>
         </p:txBody>
       </p:sp>
@@ -473,12 +471,10 @@
           <a:bodyPr wrap="square"/>
           <a:lstStyle/>
           <a:p>
-            <a:pPr/>
             <a:r>
-              <a:rPr lang="en-US" dirty="0" sz="2400" b="1"/>
+              <a:rPr lang="en-US" sz="2400" b="1" dirty="0"/>
               <a:t>Cube Slide</a:t>
             </a:r>
-            <a:endParaRPr lang="en-US"/>
           </a:p>
         </p:txBody>
       </p:sp>
@@ -538,12 +534,10 @@
           <a:bodyPr wrap="square"/>
           <a:lstStyle/>
           <a:p>
-            <a:pPr/>
             <a:r>
-              <a:rPr lang="en-US" dirty="0" sz="2400" b="1"/>
+              <a:rPr lang="en-US" sz="2400" b="1" dirty="0"/>
               <a:t>Box Slide</a:t>
             </a:r>
-            <a:endParaRPr lang="en-US"/>
           </a:p>
         </p:txBody>
       </p:sp>

</xml_diff>